<commit_message>
Add eval-engineering presentation and enhance slide building with SVG support
- Introduced a new PowerPoint presentation file for eval-engineering.
- Updated build_deck.py to include resvg-py for rendering SVG images to PNG format before embedding in slides.
- Added a raster function to handle SVG conversion and ensure images are up-to-date.
</commit_message>
<xml_diff>
--- a/ai-engineering/01-prompt-engineering/slides/prompt-engineering.pptx
+++ b/ai-engineering/01-prompt-engineering/slides/prompt-engineering.pptx
@@ -39891,7 +39891,7 @@
         <p:spPr>
           <a:xfrm>
             <a:off x="822960" y="3464052"/>
-            <a:ext cx="5944038" cy="762000"/>
+            <a:ext cx="5944038" cy="1097280"/>
           </a:xfrm>
           <a:prstGeom prst="rect">
             <a:avLst/>
@@ -39916,7 +39916,7 @@
                 </a:solidFill>
                 <a:latin typeface="Helvetica Neue"/>
               </a:rPr>
-              <a:t>Run the notebooks:</a:t>
+              <a:t>Run the code:</a:t>
             </a:r>
             <a:r>
               <a:rPr sz="2000" i="0" b="0">
@@ -39925,7 +39925,7 @@
                 </a:solidFill>
                 <a:latin typeface="Helvetica Neue"/>
               </a:rPr>
-              <a:t> pe-lecture, pe-pal, react, pe-function-calling, pe-chatgpt-adversarial</a:t>
+              <a:t> the snippets in each note; pe-rag and context caching in 02-context/notebooks</a:t>
             </a:r>
           </a:p>
         </p:txBody>
@@ -39938,7 +39938,7 @@
         </p:nvSpPr>
         <p:spPr>
           <a:xfrm>
-            <a:off x="502920" y="4383532"/>
+            <a:off x="502920" y="4718812"/>
             <a:ext cx="106680" cy="106680"/>
           </a:xfrm>
           <a:prstGeom prst="rect">
@@ -39982,7 +39982,7 @@
         </p:nvSpPr>
         <p:spPr>
           <a:xfrm>
-            <a:off x="822960" y="4287012"/>
+            <a:off x="822960" y="4622292"/>
             <a:ext cx="5944038" cy="762000"/>
           </a:xfrm>
           <a:prstGeom prst="rect">
@@ -40030,7 +40030,7 @@
         </p:nvSpPr>
         <p:spPr>
           <a:xfrm>
-            <a:off x="502920" y="5206492"/>
+            <a:off x="502920" y="5541772"/>
             <a:ext cx="106680" cy="106680"/>
           </a:xfrm>
           <a:prstGeom prst="rect">
@@ -40074,7 +40074,7 @@
         </p:nvSpPr>
         <p:spPr>
           <a:xfrm>
-            <a:off x="822960" y="5109972"/>
+            <a:off x="822960" y="5445252"/>
             <a:ext cx="5944038" cy="762000"/>
           </a:xfrm>
           <a:prstGeom prst="rect">

</xml_diff>

<commit_message>
Add documentation for Agentic RAG in Production: the PRINCE Retrieval Stack
- Introduced a comprehensive guide detailing the architecture and processes of the PRINCE retrieval stack.
- Included sections on ingestion, query-time RAG pipeline, Text-to-SQL for structured data, and domain sub-agents.
- Added diagrams to illustrate workflows and clarify intent before retrieval.
- Emphasized the importance of metadata and context discipline across agents.
- Provided evaluation strategies for the retrieval stack and key takeaways for implementation.
</commit_message>
<xml_diff>
--- a/ai-engineering/01-prompt-engineering/slides/prompt-engineering.pptx
+++ b/ai-engineering/01-prompt-engineering/slides/prompt-engineering.pptx
@@ -12554,7 +12554,7 @@
       </p:sp>
       <p:pic>
         <p:nvPicPr>
-          <p:cNvPr id="11" name="Picture 10" descr="cot.png"/>
+          <p:cNvPr id="11" name="Picture 10" descr="wei-chain-of-thought-fig1.png"/>
           <p:cNvPicPr>
             <a:picLocks noChangeAspect="1"/>
           </p:cNvPicPr>
@@ -39891,7 +39891,7 @@
         <p:spPr>
           <a:xfrm>
             <a:off x="822960" y="3464052"/>
-            <a:ext cx="5944038" cy="1097280"/>
+            <a:ext cx="5944038" cy="762000"/>
           </a:xfrm>
           <a:prstGeom prst="rect">
             <a:avLst/>
@@ -39925,7 +39925,7 @@
                 </a:solidFill>
                 <a:latin typeface="Helvetica Neue"/>
               </a:rPr>
-              <a:t> the snippets in each note; pe-rag and context caching in 02-context/notebooks</a:t>
+              <a:t> the commented snippets in each note</a:t>
             </a:r>
           </a:p>
         </p:txBody>
@@ -39938,7 +39938,7 @@
         </p:nvSpPr>
         <p:spPr>
           <a:xfrm>
-            <a:off x="502920" y="4718812"/>
+            <a:off x="502920" y="4383532"/>
             <a:ext cx="106680" cy="106680"/>
           </a:xfrm>
           <a:prstGeom prst="rect">
@@ -39982,7 +39982,7 @@
         </p:nvSpPr>
         <p:spPr>
           <a:xfrm>
-            <a:off x="822960" y="4622292"/>
+            <a:off x="822960" y="4287012"/>
             <a:ext cx="5944038" cy="762000"/>
           </a:xfrm>
           <a:prstGeom prst="rect">
@@ -40030,7 +40030,7 @@
         </p:nvSpPr>
         <p:spPr>
           <a:xfrm>
-            <a:off x="502920" y="5541772"/>
+            <a:off x="502920" y="5206492"/>
             <a:ext cx="106680" cy="106680"/>
           </a:xfrm>
           <a:prstGeom prst="rect">
@@ -40074,7 +40074,7 @@
         </p:nvSpPr>
         <p:spPr>
           <a:xfrm>
-            <a:off x="822960" y="5445252"/>
+            <a:off x="822960" y="5109972"/>
             <a:ext cx="5944038" cy="762000"/>
           </a:xfrm>
           <a:prstGeom prst="rect">

</xml_diff>